<commit_message>
slides: final polish from the deck validation pass
Co-Authored-By: Claude Fable 5.1 <noreply@anthropic.com>
</commit_message>
<xml_diff>
--- a/slides/Tacit.pptx
+++ b/slides/Tacit.pptx
@@ -9511,7 +9511,7 @@
         <p:spPr>
           <a:xfrm>
             <a:off x="2606040" y="5266944"/>
-            <a:ext cx="1710477" cy="822960"/>
+            <a:ext cx="2158078" cy="822960"/>
           </a:xfrm>
           <a:prstGeom prst="roundRect">
             <a:avLst>
@@ -9538,7 +9538,7 @@
         <p:spPr>
           <a:xfrm>
             <a:off x="2734056" y="5358384"/>
-            <a:ext cx="887517" cy="237744"/>
+            <a:ext cx="1335118" cy="237744"/>
           </a:xfrm>
           <a:prstGeom prst="rect">
             <a:avLst/>
@@ -9577,7 +9577,7 @@
         <p:spPr>
           <a:xfrm>
             <a:off x="2734056" y="5614416"/>
-            <a:ext cx="1454445" cy="438912"/>
+            <a:ext cx="1902046" cy="438912"/>
           </a:xfrm>
           <a:prstGeom prst="rect">
             <a:avLst/>
@@ -9618,7 +9618,7 @@
         </p:nvSpPr>
         <p:spPr>
           <a:xfrm>
-            <a:off x="3621573" y="5358384"/>
+            <a:off x="4069174" y="5358384"/>
             <a:ext cx="566928" cy="182880"/>
           </a:xfrm>
           <a:prstGeom prst="roundRect">
@@ -9661,8 +9661,8 @@
         </p:nvSpPr>
         <p:spPr>
           <a:xfrm>
-            <a:off x="4426245" y="5266944"/>
-            <a:ext cx="1710477" cy="822960"/>
+            <a:off x="4873846" y="5266944"/>
+            <a:ext cx="1598576" cy="822960"/>
           </a:xfrm>
           <a:prstGeom prst="roundRect">
             <a:avLst>
@@ -9688,8 +9688,8 @@
         </p:nvSpPr>
         <p:spPr>
           <a:xfrm>
-            <a:off x="4554261" y="5358384"/>
-            <a:ext cx="1454445" cy="237744"/>
+            <a:off x="5001862" y="5358384"/>
+            <a:ext cx="1342544" cy="237744"/>
           </a:xfrm>
           <a:prstGeom prst="rect">
             <a:avLst/>
@@ -9727,8 +9727,8 @@
         </p:nvSpPr>
         <p:spPr>
           <a:xfrm>
-            <a:off x="4554261" y="5614416"/>
-            <a:ext cx="1454445" cy="438912"/>
+            <a:off x="5001862" y="5614416"/>
+            <a:ext cx="1342544" cy="438912"/>
           </a:xfrm>
           <a:prstGeom prst="rect">
             <a:avLst/>
@@ -9769,8 +9769,8 @@
         </p:nvSpPr>
         <p:spPr>
           <a:xfrm>
-            <a:off x="6246449" y="5266944"/>
-            <a:ext cx="1710477" cy="822960"/>
+            <a:off x="6582150" y="5266944"/>
+            <a:ext cx="1598576" cy="822960"/>
           </a:xfrm>
           <a:prstGeom prst="roundRect">
             <a:avLst>
@@ -9796,8 +9796,8 @@
         </p:nvSpPr>
         <p:spPr>
           <a:xfrm>
-            <a:off x="6374465" y="5358384"/>
-            <a:ext cx="1454445" cy="237744"/>
+            <a:off x="6710166" y="5358384"/>
+            <a:ext cx="1342544" cy="237744"/>
           </a:xfrm>
           <a:prstGeom prst="rect">
             <a:avLst/>
@@ -9835,8 +9835,8 @@
         </p:nvSpPr>
         <p:spPr>
           <a:xfrm>
-            <a:off x="6374465" y="5614416"/>
-            <a:ext cx="1454445" cy="438912"/>
+            <a:off x="6710166" y="5614416"/>
+            <a:ext cx="1342544" cy="438912"/>
           </a:xfrm>
           <a:prstGeom prst="rect">
             <a:avLst/>
@@ -9877,8 +9877,8 @@
         </p:nvSpPr>
         <p:spPr>
           <a:xfrm>
-            <a:off x="8066654" y="5266944"/>
-            <a:ext cx="1710477" cy="822960"/>
+            <a:off x="8290455" y="5266944"/>
+            <a:ext cx="1598576" cy="822960"/>
           </a:xfrm>
           <a:prstGeom prst="roundRect">
             <a:avLst>
@@ -9904,8 +9904,8 @@
         </p:nvSpPr>
         <p:spPr>
           <a:xfrm>
-            <a:off x="8194670" y="5358384"/>
-            <a:ext cx="1454445" cy="237744"/>
+            <a:off x="8418471" y="5358384"/>
+            <a:ext cx="1342544" cy="237744"/>
           </a:xfrm>
           <a:prstGeom prst="rect">
             <a:avLst/>
@@ -9943,8 +9943,8 @@
         </p:nvSpPr>
         <p:spPr>
           <a:xfrm>
-            <a:off x="8194670" y="5614416"/>
-            <a:ext cx="1454445" cy="438912"/>
+            <a:off x="8418471" y="5614416"/>
+            <a:ext cx="1342544" cy="438912"/>
           </a:xfrm>
           <a:prstGeom prst="rect">
             <a:avLst/>
@@ -9985,8 +9985,8 @@
         </p:nvSpPr>
         <p:spPr>
           <a:xfrm>
-            <a:off x="9886859" y="5266944"/>
-            <a:ext cx="1710477" cy="822960"/>
+            <a:off x="9998759" y="5266944"/>
+            <a:ext cx="1598576" cy="822960"/>
           </a:xfrm>
           <a:prstGeom prst="roundRect">
             <a:avLst>
@@ -10012,8 +10012,8 @@
         </p:nvSpPr>
         <p:spPr>
           <a:xfrm>
-            <a:off x="10014875" y="5358384"/>
-            <a:ext cx="1454445" cy="237744"/>
+            <a:off x="10126775" y="5358384"/>
+            <a:ext cx="1342544" cy="237744"/>
           </a:xfrm>
           <a:prstGeom prst="rect">
             <a:avLst/>
@@ -10051,8 +10051,8 @@
         </p:nvSpPr>
         <p:spPr>
           <a:xfrm>
-            <a:off x="10014875" y="5614416"/>
-            <a:ext cx="1454445" cy="438912"/>
+            <a:off x="10126775" y="5614416"/>
+            <a:ext cx="1342544" cy="438912"/>
           </a:xfrm>
           <a:prstGeom prst="rect">
             <a:avLst/>

</xml_diff>